<commit_message>
Deck + README: define ShubhLabh's Intelli AI
</commit_message>
<xml_diff>
--- a/docs/pitch/ShubhLabh_AI_Pitch_Deck_v4.pptx
+++ b/docs/pitch/ShubhLabh_AI_Pitch_Deck_v4.pptx
@@ -34280,13 +34280,13 @@
                 </a:lnSpc>
               </a:pPr>
               <a:r>
-                <a:rPr sz="850" b="0" i="0">
+                <a:rPr sz="700" b="0" i="0">
                   <a:solidFill>
                     <a:srgbClr val="4B5563"/>
                   </a:solidFill>
                   <a:latin typeface="Segoe UI"/>
                 </a:rPr>
-                <a:t>Guard pack on every offer and every line of copy: MRP · honest % off vs 30-day low · same price for everyone · margin floor · dark-pattern lint · injection quarantine · number check · PII redaction</a:t>
+                <a:t>Our own in-house AI agent. In the background it re-checks every calculation on every offer: MRP, honest % off vs the 30-day low, margin, break-even and budget, plus copy lint and injection quarantine. It then gives a confidence score: a 90% chance of at least ₹X extra profit, from the 200-scenario risk check.</a:t>
               </a:r>
             </a:p>
           </p:txBody>

</xml_diff>